<commit_message>
Slides: sd-13-024 keepalive count, sd-13-025 describe names the pod
Co-Authored-By: Claude Opus 5.5 <noreply@anthropic.com>
Claude-Session: https://claude.ai/code/session_01TQmrJYLm4GPgtXpQaEk7ey
</commit_message>
<xml_diff>
--- a/system-design-101/vi/lessons/sd-13-024/slides/sd-13-024.pptx
+++ b/system-design-101/vi/lessons/sd-13-024/slides/sd-13-024.pptx
@@ -9279,6 +9279,17 @@
               <a:t>keepalive</a:t>
             </a:r>
             <a:r>
+              <a:rPr lang="en-US" sz="2100" b="1" dirty="0" spc="-1" kern="0">
+                <a:solidFill>
+                  <a:srgbClr val="F3EEE3"/>
+                </a:solidFill>
+                <a:latin typeface="Be Vietnam Pro" pitchFamily="34" charset="0"/>
+                <a:ea typeface="Be Vietnam Pro" pitchFamily="34" charset="-122"/>
+                <a:cs typeface="Be Vietnam Pro" pitchFamily="34" charset="-120"/>
+              </a:rPr>
+              <a:t> 32;</a:t>
+            </a:r>
+            <a:r>
               <a:rPr lang="en-US" sz="2100" b="1" dirty="0" spc="-12" kern="0">
                 <a:solidFill>
                   <a:srgbClr val="F3EEE3"/>

</xml_diff>